<commit_message>
minor changes to several slides
</commit_message>
<xml_diff>
--- a/PowerPoints/04 - Definition of CPRL.pptx
+++ b/PowerPoints/04 - Definition of CPRL.pptx
@@ -4634,7 +4634,7 @@
           <a:p>
             <a:r>
               <a:rPr lang="en-US" dirty="0"/>
-              <a:t>Array, record, and string variables can be declared without first having to create a new array type.</a:t>
+              <a:t>Array and string variables can be declared without first having to create a new type.</a:t>
             </a:r>
           </a:p>
           <a:p>
@@ -4645,7 +4645,18 @@
               <a:rPr lang="en-US" sz="1800" dirty="0">
                 <a:latin typeface="Consolas" panose="020B0609020204030204" pitchFamily="49" charset="0"/>
               </a:rPr>
-              <a:t>var a : array[10] of Integer; </a:t>
+              <a:t>var a : array[10] of Integer;</a:t>
+            </a:r>
+          </a:p>
+          <a:p>
+            <a:pPr marL="457200" lvl="1" indent="0">
+              <a:buNone/>
+            </a:pPr>
+            <a:r>
+              <a:rPr lang="en-US" sz="1800" dirty="0">
+                <a:latin typeface="Consolas" panose="020B0609020204030204" pitchFamily="49" charset="0"/>
+              </a:rPr>
+              <a:t>var s : string[50]; </a:t>
             </a:r>
           </a:p>
           <a:p>
@@ -4671,7 +4682,7 @@
             </a:r>
             <a:r>
               <a:rPr lang="en-US" dirty="0"/>
-              <a:t>”.  Nested composite literal values are used for nested composite types; e.g., arrays of records.</a:t>
+              <a:t>”.  Nested composite literal values are used for nested composite types; e.g., arrays of arrays or arrays of records.</a:t>
             </a:r>
           </a:p>
           <a:p>

</xml_diff>